<commit_message>
[bug] fix text color in placeholder
</commit_message>
<xml_diff>
--- a/slide/themes/src/24_memory book.pptx
+++ b/slide/themes/src/24_memory book.pptx
@@ -14643,39 +14643,93 @@
           <a:lstStyle>
             <a:lvl1pPr marL="0" indent="0">
               <a:buNone/>
-              <a:defRPr sz="1600"/>
+              <a:defRPr sz="1600">
+                <a:solidFill>
+                  <a:schemeClr val="accent6">
+                    <a:lumMod val="50000"/>
+                  </a:schemeClr>
+                </a:solidFill>
+              </a:defRPr>
             </a:lvl1pPr>
             <a:lvl2pPr marL="457200" indent="0">
               <a:buNone/>
-              <a:defRPr sz="1400"/>
+              <a:defRPr sz="1400">
+                <a:solidFill>
+                  <a:schemeClr val="accent6">
+                    <a:lumMod val="50000"/>
+                  </a:schemeClr>
+                </a:solidFill>
+              </a:defRPr>
             </a:lvl2pPr>
             <a:lvl3pPr marL="914400" indent="0">
               <a:buNone/>
-              <a:defRPr sz="1200"/>
+              <a:defRPr sz="1200">
+                <a:solidFill>
+                  <a:schemeClr val="accent6">
+                    <a:lumMod val="50000"/>
+                  </a:schemeClr>
+                </a:solidFill>
+              </a:defRPr>
             </a:lvl3pPr>
             <a:lvl4pPr marL="1371600" indent="0">
               <a:buNone/>
-              <a:defRPr sz="1000"/>
+              <a:defRPr sz="1000">
+                <a:solidFill>
+                  <a:schemeClr val="accent6">
+                    <a:lumMod val="50000"/>
+                  </a:schemeClr>
+                </a:solidFill>
+              </a:defRPr>
             </a:lvl4pPr>
             <a:lvl5pPr marL="1828800" indent="0">
               <a:buNone/>
-              <a:defRPr sz="1000"/>
+              <a:defRPr sz="1000">
+                <a:solidFill>
+                  <a:schemeClr val="accent6">
+                    <a:lumMod val="50000"/>
+                  </a:schemeClr>
+                </a:solidFill>
+              </a:defRPr>
             </a:lvl5pPr>
             <a:lvl6pPr marL="2286000" indent="0">
               <a:buNone/>
-              <a:defRPr sz="1000"/>
+              <a:defRPr sz="1000">
+                <a:solidFill>
+                  <a:schemeClr val="accent6">
+                    <a:lumMod val="50000"/>
+                  </a:schemeClr>
+                </a:solidFill>
+              </a:defRPr>
             </a:lvl6pPr>
             <a:lvl7pPr marL="2743200" indent="0">
               <a:buNone/>
-              <a:defRPr sz="1000"/>
+              <a:defRPr sz="1000">
+                <a:solidFill>
+                  <a:schemeClr val="accent6">
+                    <a:lumMod val="50000"/>
+                  </a:schemeClr>
+                </a:solidFill>
+              </a:defRPr>
             </a:lvl7pPr>
             <a:lvl8pPr marL="3200400" indent="0">
               <a:buNone/>
-              <a:defRPr sz="1000"/>
+              <a:defRPr sz="1000">
+                <a:solidFill>
+                  <a:schemeClr val="accent6">
+                    <a:lumMod val="50000"/>
+                  </a:schemeClr>
+                </a:solidFill>
+              </a:defRPr>
             </a:lvl8pPr>
             <a:lvl9pPr marL="3657600" indent="0">
               <a:buNone/>
-              <a:defRPr sz="1000"/>
+              <a:defRPr sz="1000">
+                <a:solidFill>
+                  <a:schemeClr val="accent6">
+                    <a:lumMod val="50000"/>
+                  </a:schemeClr>
+                </a:solidFill>
+              </a:defRPr>
             </a:lvl9pPr>
           </a:lstStyle>
           <a:p>

</xml_diff>